<commit_message>
Clarify Case 09 slide headings and terminology
Co-authored-by: arena-agent <297053741+arena-agent@users.noreply.github.com>
</commit_message>
<xml_diff>
--- a/Caso_09_UCP.pptx
+++ b/Caso_09_UCP.pptx
@@ -3362,7 +3362,7 @@
                 </a:solidFill>
                 <a:latin typeface="Montserrat"/>
               </a:rPr>
-              <a:t>Caso 09: dolor abdominal y lesión pancreática</a:t>
+              <a:t>Caso clínico 09: enfoque integral de la pancreatitis aguda</a:t>
             </a:r>
           </a:p>
         </p:txBody>
@@ -3550,7 +3550,7 @@
                 </a:solidFill>
                 <a:latin typeface="Montserrat"/>
               </a:rPr>
-              <a:t>MICROFOTOGRAFÍA OFICIAL H&amp;E</a:t>
+              <a:t>MICROSCOPÍA EN H&amp;E</a:t>
             </a:r>
           </a:p>
         </p:txBody>
@@ -3592,7 +3592,7 @@
                 </a:solidFill>
                 <a:latin typeface="Montserrat"/>
               </a:rPr>
-              <a:t>El calcio marca los adipocitos lesionados</a:t>
+              <a:t>Esteatonecrosis pancreática en la microfotografía H&amp;E</a:t>
             </a:r>
           </a:p>
         </p:txBody>
@@ -3896,7 +3896,7 @@
                 </a:solidFill>
                 <a:latin typeface="Montserrat"/>
               </a:rPr>
-              <a:t>H&amp;E: adipocitos necróticos y depósitos basófilos de calcio; correlacionar con acinos y vasos.</a:t>
+              <a:t>H&amp;E (hematoxilina-eosina): adipocitos necróticos y depósitos basófilos de calcio.</a:t>
             </a:r>
           </a:p>
         </p:txBody>
@@ -3998,7 +3998,7 @@
                 </a:solidFill>
                 <a:latin typeface="Montserrat"/>
               </a:rPr>
-              <a:t>CORRELACIÓN MORFOLÓGICA</a:t>
+              <a:t>PATRONES MORFOLÓGICOS</a:t>
             </a:r>
           </a:p>
         </p:txBody>
@@ -4040,7 +4040,7 @@
                 </a:solidFill>
                 <a:latin typeface="Montserrat"/>
               </a:rPr>
-              <a:t>Edema intersticial y necrosis no son el mismo patrón</a:t>
+              <a:t>Pancreatitis intersticial y necrotizante: diferencias morfológicas</a:t>
             </a:r>
           </a:p>
         </p:txBody>
@@ -4844,7 +4844,7 @@
                 </a:solidFill>
                 <a:latin typeface="Montserrat"/>
               </a:rPr>
-              <a:t>SELECCIÓN DE ESTUDIO</a:t>
+              <a:t>ESTUDIOS DE IMAGEN</a:t>
             </a:r>
           </a:p>
         </p:txBody>
@@ -4886,7 +4886,7 @@
                 </a:solidFill>
                 <a:latin typeface="Montserrat"/>
               </a:rPr>
-              <a:t>Cada ventana responde una pregunta distinta</a:t>
+              <a:t>Estudios de imagen: qué aporta cada modalidad y cuándo usarla</a:t>
             </a:r>
           </a:p>
         </p:txBody>
@@ -5980,7 +5980,7 @@
                 </a:solidFill>
                 <a:latin typeface="Montserrat"/>
               </a:rPr>
-              <a:t>Índice tomográfico</a:t>
+              <a:t>Índice CTSI de Balthazar</a:t>
             </a:r>
           </a:p>
           <a:p>
@@ -6134,7 +6134,7 @@
                 </a:solidFill>
                 <a:latin typeface="Montserrat"/>
               </a:rPr>
-              <a:t>CTSI = grado A–E (0–4) + necrosis (0; &lt;30%=2; 30–50%=4; &gt;50%=6) = 0–10. No sustituye Atlanta.</a:t>
+              <a:t>CTSI (índice de gravedad por TC): grado A–E (0–4) + necrosis (0; &lt;30%=2; 30–50%=4; &gt;50%=6) = 0–10.</a:t>
             </a:r>
           </a:p>
         </p:txBody>
@@ -6194,7 +6194,7 @@
                 </a:solidFill>
                 <a:latin typeface="Montserrat"/>
               </a:rPr>
-              <a:t>SEMIÓTICA ECOGRÁFICA</a:t>
+              <a:t>ECOGRAFÍA BILIAR</a:t>
             </a:r>
           </a:p>
         </p:txBody>
@@ -6236,7 +6236,7 @@
                 </a:solidFill>
                 <a:latin typeface="Montserrat"/>
               </a:rPr>
-              <a:t>La ecografía distingue cálculos de imitadores</a:t>
+              <a:t>Ecografía biliar: cálculo, barro y pólipo</a:t>
             </a:r>
           </a:p>
         </p:txBody>
@@ -7132,7 +7132,7 @@
                 </a:solidFill>
                 <a:latin typeface="Montserrat"/>
               </a:rPr>
-              <a:t>SOPORTE AGUDO</a:t>
+              <a:t>TRATAMIENTO INICIAL</a:t>
             </a:r>
           </a:p>
         </p:txBody>
@@ -7174,7 +7174,7 @@
                 </a:solidFill>
                 <a:latin typeface="Montserrat"/>
               </a:rPr>
-              <a:t>Tratar la fisiología, no perseguir profilaxis antibiótica</a:t>
+              <a:t>Manejo inicial: hidratación, analgesia, antibióticos y nutrición</a:t>
             </a:r>
           </a:p>
         </p:txBody>
@@ -7756,7 +7756,7 @@
                 </a:solidFill>
                 <a:latin typeface="Montserrat"/>
               </a:rPr>
-              <a:t>La carga alta de Cl⁻ puede causar acidosis hiperclorémica; el efecto del pH sobre zimógenos es experimental, no causalidad clínica probada.</a:t>
+              <a:t>El exceso de cloruro (Cl⁻) puede causar acidosis hiperclorémica; el efecto del pH sobre zimógenos es experimental, no causalidad clínica probada.</a:t>
             </a:r>
           </a:p>
         </p:txBody>
@@ -8371,7 +8371,7 @@
                 </a:solidFill>
                 <a:latin typeface="Montserrat"/>
               </a:rPr>
-              <a:t>Alimentación oral temprana si se tolera. CPRE ante colangitis u obstrucción persistente, no de rutina sin colangitis.</a:t>
+              <a:t>Alimentación oral temprana si se tolera. CPRE (colangiopancreatografía retrógrada endoscópica) ante colangitis u obstrucción biliar persistente.</a:t>
             </a:r>
           </a:p>
         </p:txBody>
@@ -8413,7 +8413,7 @@
                 </a:solidFill>
                 <a:latin typeface="Montserrat"/>
               </a:rPr>
-              <a:t>ACG 2024: hidratación moderada individualizada, analgesia, nutrición temprana y antibióticos solo ante infección.</a:t>
+              <a:t>ACG 2024: hidratación moderada, analgesia y nutrición temprana; antibióticos solo ante infección.</a:t>
             </a:r>
           </a:p>
         </p:txBody>
@@ -8473,7 +8473,7 @@
                 </a:solidFill>
                 <a:latin typeface="Montserrat"/>
               </a:rPr>
-              <a:t>PREVENCIÓN DE NUEVA LESIÓN BILIAR</a:t>
+              <a:t>PREVENCIÓN SECUNDARIA</a:t>
             </a:r>
           </a:p>
         </p:txBody>
@@ -8515,7 +8515,7 @@
                 </a:solidFill>
                 <a:latin typeface="Montserrat"/>
               </a:rPr>
-              <a:t>La colecistectomía oportuna cierra el ciclo causal</a:t>
+              <a:t>Prevención de recurrencia: colecistectomía en pancreatitis biliar</a:t>
             </a:r>
           </a:p>
         </p:txBody>
@@ -8905,7 +8905,7 @@
                 </a:solidFill>
                 <a:latin typeface="Montserrat"/>
               </a:rPr>
-              <a:t>Evento biliar compuesto: cirugía diferida frente a la misma hospitalización (PONCHO; 6 meses)</a:t>
+              <a:t>Desenlace compuesto: reingreso por complicación biliar o muerte; cirugía diferida vs mismo ingreso (6 meses).</a:t>
             </a:r>
           </a:p>
         </p:txBody>
@@ -9382,7 +9382,7 @@
                 </a:solidFill>
                 <a:latin typeface="Montserrat"/>
               </a:rPr>
-              <a:t>No afirmar 30% en 3 meses sin fuente primaria. PONCHO informó 17% vs 5% de eventos compuestos con estrategia diferida vs misma admisión.</a:t>
+              <a:t>No afirmar «30 % en 3 meses» sin fuente. PONCHO: reingreso por complicación biliar o muerte, 17 % diferida vs 5 % en el mismo ingreso a 6 meses.</a:t>
             </a:r>
           </a:p>
         </p:txBody>
@@ -9484,7 +9484,7 @@
                 </a:solidFill>
                 <a:latin typeface="Montserrat"/>
               </a:rPr>
-              <a:t>SALIDA Y REPARACIÓN</a:t>
+              <a:t>SEGUIMIENTO TRAS EL ALTA</a:t>
             </a:r>
           </a:p>
         </p:txBody>
@@ -9526,7 +9526,7 @@
                 </a:solidFill>
                 <a:latin typeface="Montserrat"/>
               </a:rPr>
-              <a:t>El seguimiento busca síntomas persistentes, no una imagen automática</a:t>
+              <a:t>Seguimiento tras el alta: síntomas y colecciones pancreáticas</a:t>
             </a:r>
           </a:p>
         </p:txBody>
@@ -10599,7 +10599,7 @@
                 </a:solidFill>
                 <a:latin typeface="Montserrat"/>
               </a:rPr>
-              <a:t>Pseudoquiste tras pancreatitis intersticial; necrosis encapsulada si hay detritos.</a:t>
+              <a:t>Pseudoquiste: colección encapsulada sin detritos; necrosis encapsulada: contiene detritos.</a:t>
             </a:r>
           </a:p>
         </p:txBody>
@@ -10972,7 +10972,7 @@
                 </a:solidFill>
                 <a:latin typeface="Montserrat"/>
               </a:rPr>
-              <a:t>FUENTES · DIAGNÓSTICO, MECANISMOS Y MANEJO</a:t>
+              <a:t>BIBLIOGRAFÍA CLÍNICA COMPLEMENTARIA</a:t>
             </a:r>
           </a:p>
         </p:txBody>
@@ -11014,7 +11014,7 @@
                 </a:solidFill>
                 <a:latin typeface="Montserrat"/>
               </a:rPr>
-              <a:t>Fuentes que sustentan el diagnóstico y el manejo</a:t>
+              <a:t>Fuentes complementarias: diagnóstico y manejo</a:t>
             </a:r>
           </a:p>
         </p:txBody>
@@ -11880,7 +11880,7 @@
                 </a:solidFill>
                 <a:latin typeface="Montserrat"/>
               </a:rPr>
-              <a:t>FUENTES · ANATOMÍA, MORFOLOGÍA E IMAGEN</a:t>
+              <a:t>BIBLIOGRAFÍA DE ANATOMÍA E IMAGEN</a:t>
             </a:r>
           </a:p>
         </p:txBody>
@@ -11922,7 +11922,7 @@
                 </a:solidFill>
                 <a:latin typeface="Montserrat"/>
               </a:rPr>
-              <a:t>Fuentes que sostienen la anatomía y la morfología</a:t>
+              <a:t>Fuentes complementarias: anatomía, patología e imagen</a:t>
             </a:r>
           </a:p>
         </p:txBody>
@@ -13264,7 +13264,7 @@
                 </a:solidFill>
                 <a:latin typeface="Montserrat"/>
               </a:rPr>
-              <a:t>EQUIPO Y RESPONSABILIDADES</a:t>
+              <a:t>ORGANIZACIÓN DE LA EXPOSICIÓN</a:t>
             </a:r>
           </a:p>
         </p:txBody>
@@ -13306,7 +13306,7 @@
                 </a:solidFill>
                 <a:latin typeface="Montserrat"/>
               </a:rPr>
-              <a:t>Una defensa común, cuatro tramos</a:t>
+              <a:t>Organización del equipo y orden de exposición</a:t>
             </a:r>
           </a:p>
         </p:txBody>
@@ -14470,7 +14470,7 @@
                 </a:solidFill>
                 <a:latin typeface="Montserrat"/>
               </a:rPr>
-              <a:t>INGRESO Y SECUENCIA TEMPORAL</a:t>
+              <a:t>HISTORIA CLÍNICA</a:t>
             </a:r>
           </a:p>
         </p:txBody>
@@ -14512,7 +14512,7 @@
                 </a:solidFill>
                 <a:latin typeface="Montserrat"/>
               </a:rPr>
-              <a:t>El dolor ordena la anamnesis</a:t>
+              <a:t>Historia clínica: cronología del dolor y antecedentes</a:t>
             </a:r>
           </a:p>
         </p:txBody>
@@ -15440,7 +15440,7 @@
                 </a:solidFill>
                 <a:latin typeface="Montserrat"/>
               </a:rPr>
-              <a:t>DECISIÓN EN URGENCIAS</a:t>
+              <a:t>DIAGNÓSTICO Y GRAVEDAD</a:t>
             </a:r>
           </a:p>
         </p:txBody>
@@ -15482,7 +15482,7 @@
                 </a:solidFill>
                 <a:latin typeface="Montserrat"/>
               </a:rPr>
-              <a:t>Dos de tres criterios sostienen el diagnóstico</a:t>
+              <a:t>Diagnóstico de pancreatitis y clasificación de gravedad</a:t>
             </a:r>
           </a:p>
         </p:txBody>
@@ -15832,7 +15832,7 @@
                 </a:solidFill>
                 <a:latin typeface="Montserrat"/>
               </a:rPr>
-              <a:t>≥2/3: dolor típico; lipasa o amilasa ≥3× LSN; imagen característica.</a:t>
+              <a:t>≥2 de 3: dolor típico; lipasa o amilasa ≥3 veces el límite superior normal (LSN); o imagen característica.</a:t>
             </a:r>
           </a:p>
         </p:txBody>
@@ -16468,7 +16468,7 @@
                 </a:solidFill>
                 <a:latin typeface="Montserrat"/>
               </a:rPr>
-              <a:t>OBSTRUCCIÓN Y ETIOLOGÍA BILIAR</a:t>
+              <a:t>MECANISMO BILIAR PROPUESTO</a:t>
             </a:r>
           </a:p>
         </p:txBody>
@@ -16510,7 +16510,7 @@
                 </a:solidFill>
                 <a:latin typeface="Montserrat"/>
               </a:rPr>
-              <a:t>La teoría de Opie vincula obstrucción y lesión acinar</a:t>
+              <a:t>Etiología biliar: mecanismo de obstrucción propuesto por Opie</a:t>
             </a:r>
           </a:p>
         </p:txBody>
@@ -17818,7 +17818,7 @@
                 </a:solidFill>
                 <a:latin typeface="Montserrat"/>
               </a:rPr>
-              <a:t>UMBRAL DE DAÑO CELULAR</a:t>
+              <a:t>LESIÓN DEL ACINO PANCREÁTICO</a:t>
             </a:r>
           </a:p>
         </p:txBody>
@@ -17860,7 +17860,7 @@
                 </a:solidFill>
                 <a:latin typeface="Montserrat"/>
               </a:rPr>
-              <a:t>La tumefacción puede revertir; la ruptura de membrana no</a:t>
+              <a:t>Lesión celular: cambios reversibles e irreversibles</a:t>
             </a:r>
           </a:p>
         </p:txBody>
@@ -18664,7 +18664,7 @@
                 </a:solidFill>
                 <a:latin typeface="Montserrat"/>
               </a:rPr>
-              <a:t>LESIÓN ACINAR Y MEDIADORES</a:t>
+              <a:t>ACTIVACIÓN ENZIMÁTICA E INFLAMACIÓN</a:t>
             </a:r>
           </a:p>
         </p:txBody>
@@ -18706,7 +18706,7 @@
                 </a:solidFill>
                 <a:latin typeface="Montserrat"/>
               </a:rPr>
-              <a:t>La activación precoz amplifica el daño local y sistémico</a:t>
+              <a:t>Activación de enzimas e inflamación pancreática</a:t>
             </a:r>
           </a:p>
         </p:txBody>
@@ -19822,7 +19822,7 @@
                 </a:solidFill>
                 <a:latin typeface="Montserrat"/>
               </a:rPr>
-              <a:t>Histamina actúa rápido; TNF-α, IL-1/IL-6 y eicosanoides amplifican inflamación.</a:t>
+              <a:t>Histamina actúa rápido; TNF-α e interleucinas 1 y 6 (IL-1/IL-6) amplifican la inflamación.</a:t>
             </a:r>
           </a:p>
         </p:txBody>
@@ -20014,7 +20014,7 @@
                 </a:solidFill>
                 <a:latin typeface="Montserrat"/>
               </a:rPr>
-              <a:t>TRADUCCIÓN AL EXAMEN CLÍNICO</a:t>
+              <a:t>MANIFESTACIONES CLÍNICAS</a:t>
             </a:r>
           </a:p>
         </p:txBody>
@@ -20056,7 +20056,7 @@
                 </a:solidFill>
                 <a:latin typeface="Montserrat"/>
               </a:rPr>
-              <a:t>El plexo explica la irradiación; los signos cutáneos no descartan</a:t>
+              <a:t>Manifestaciones clínicas: dolor referido, íleo y equimosis</a:t>
             </a:r>
           </a:p>
         </p:txBody>
@@ -20494,7 +20494,7 @@
                 </a:solidFill>
                 <a:latin typeface="Montserrat"/>
               </a:rPr>
-              <a:t>CELSO / GALENO</a:t>
+              <a:t>SIGNOS DE CELSO Y GALENO</a:t>
             </a:r>
           </a:p>
         </p:txBody>
@@ -20584,7 +20584,7 @@
                 </a:solidFill>
                 <a:latin typeface="Montserrat"/>
               </a:rPr>
-              <a:t>Tétrada: rubor, calor, tumor, dolor. Péntada: añade functio laesa (pérdida de función).</a:t>
+              <a:t>Tétrada de Celso: rubor, calor, tumor, dolor. Galeno añade functio laesa (pérdida de función).</a:t>
             </a:r>
           </a:p>
         </p:txBody>
@@ -21220,7 +21220,7 @@
                 </a:solidFill>
                 <a:latin typeface="Montserrat"/>
               </a:rPr>
-              <a:t>PIEZA MACROSCÓPICA</a:t>
+              <a:t>PATOLOGÍA MACROSCÓPICA</a:t>
             </a:r>
           </a:p>
         </p:txBody>
@@ -21262,7 +21262,7 @@
                 </a:solidFill>
                 <a:latin typeface="Montserrat"/>
               </a:rPr>
-              <a:t>La saponificación dibuja gotas cerosas</a:t>
+              <a:t>Esteatonecrosis pancreática en la pieza macroscópica</a:t>
             </a:r>
           </a:p>
         </p:txBody>
@@ -21566,7 +21566,7 @@
                 </a:solidFill>
                 <a:latin typeface="Montserrat"/>
               </a:rPr>
-              <a:t>La lipasa libera ácidos grasos; con Ca²⁺ forman jabones insolubles visibles como focos blancos cerosos.</a:t>
+              <a:t>La lipasa libera ácidos grasos que se unen al calcio (Ca²⁺) y forman jabones insolubles blancos.</a:t>
             </a:r>
           </a:p>
         </p:txBody>

</xml_diff>